<commit_message>
Presentation: platform-wide story, new architecture diagram with the upload path
Co-Authored-By: Claude Sonnet 5.5 <noreply@anthropic.com>
</commit_message>
<xml_diff>
--- a/docs/Mini_Project_Presentation.pptx
+++ b/docs/Mini_Project_Presentation.pptx
@@ -886,7 +886,7 @@
           <a:lstStyle/>
           <a:p>
             <a:r>
-              <a:t>Introduce the project, the team and the guide. One sentence: a big-data system that finds fraud among 6.36 million bank transactions and lets an analyst search, investigate and upload data.</a:t>
+              <a:t>Introduce the project, the team and the guide. One sentence: a fraud analytics platform that takes transaction data from a batch pipeline or a CSV upload to model scores, instant search and investigated cases.</a:t>
             </a:r>
           </a:p>
         </p:txBody>
@@ -989,7 +989,7 @@
           <a:lstStyle/>
           <a:p>
             <a:r>
-              <a:t>Summarise: accurate model, instant search, a full case workflow and upload at scale. Be open about the limits: simulated data, local-mode Spark and no authentication.</a:t>
+              <a:t>Summarise: one platform from data to investigated case, an accurate model, instant search on every dataset, a full case workflow and upload at scale. Be open about the limits: simulated data, local-mode Spark and no authentication.</a:t>
             </a:r>
           </a:p>
         </p:txBody>
@@ -1092,7 +1092,7 @@
           <a:lstStyle/>
           <a:p>
             <a:r>
-              <a:t>Foundational papers for the model, the engine, the dataset, the evaluation and the index, plus the documentation of the tools used.</a:t>
+              <a:t>Foundational papers for the model, the engine, columnar storage, the evaluation and the index, the documentation of the tools used, and the benchmark data.</a:t>
             </a:r>
           </a:p>
         </p:txBody>
@@ -1195,7 +1195,7 @@
           <a:lstStyle/>
           <a:p>
             <a:r>
-              <a:t>Fraud is about 1 in 776 transactions. Accuracy is meaningless; we judge with precision and recall. The gap is a complete system: scale, millisecond search, a case workflow and file upload.</a:t>
+              <a:t>The problem is not only detecting fraud but working with it: rare events, scale, slow lookups and no workflow. The gap is a complete platform: scalable processing, accurate detection, millisecond search, a case workflow and file upload.</a:t>
             </a:r>
           </a:p>
         </p:txBody>
@@ -1401,7 +1401,7 @@
           <a:lstStyle/>
           <a:p>
             <a:r>
-              <a:t>The dataset (PaySim), how others handle imbalance (SMOTE), and why we use precision-recall metrics.</a:t>
+              <a:t>Why columnar storage (C-Store), how others handle imbalance (SMOTE), and why we use precision-recall metrics.</a:t>
             </a:r>
           </a:p>
         </p:txBody>
@@ -1607,7 +1607,7 @@
           <a:lstStyle/>
           <a:p>
             <a:r>
-              <a:t>Four objectives: process the data at scale, detect the rare fraud accurately, make search instant, and support investigation and upload.</a:t>
+              <a:t>Four objectives: scalable processing for any data, accurate detection, instant search on every dataset, and a workflow for investigation.</a:t>
             </a:r>
           </a:p>
         </p:txBody>
@@ -1710,7 +1710,7 @@
           <a:lstStyle/>
           <a:p>
             <a:r>
-              <a:t>Top half is the offline batch pipeline run once with Spark. Bottom half is the always-on application: a REST API that reads the index, the model and the stored results, and reads and writes cases and uploads.</a:t>
+              <a:t>Two ways in: bulk historical data goes through the Spark batch pipeline; uploaded CSV files go through the streaming upload job. Both produce the same things: scores from the trained model, a search index and analytics. One REST API serves the web interface, and the interface works on whichever dataset is selected.</a:t>
             </a:r>
           </a:p>
         </p:txBody>
@@ -1813,7 +1813,7 @@
           <a:lstStyle/>
           <a:p>
             <a:r>
-              <a:t>Five parts: the batch pipeline, the fraud model, millisecond search, case management, and upload with batch scoring.</a:t>
+              <a:t>Five parts: the data platform with two ways in, the fraud model, millisecond search on every dataset, case management, and one interface over a REST API.</a:t>
             </a:r>
           </a:p>
         </p:txBody>
@@ -1916,7 +1916,7 @@
           <a:lstStyle/>
           <a:p>
             <a:r>
-              <a:t>Table 1: the Random Forest finds 2,401 of 2,407 frauds with 17 false alarms; the baseline raises 48,466. Table 2: the indexed lookup is 574 times faster than a Spark scan. On unseen generated files recall stays high but precision drops to 51.8%, an honest result on a different dataset.</a:t>
+              <a:t>Table 1: the Random Forest finds 2,401 of 2,407 frauds with 17 false alarms; the baseline raises 48,466. Table 2 shows the platform: indexed lookup 574 times faster than a Spark scan, fast suggestions, high scoring throughput, and uploads of 8 million rows scored and indexed in about 70 seconds. On an unseen uploaded file recall stays high but precision drops to 51.8%.</a:t>
             </a:r>
           </a:p>
         </p:txBody>
@@ -11929,7 +11929,7 @@
                 <a:cs typeface="Times New Roman"/>
                 <a:sym typeface="Times New Roman"/>
               </a:rPr>
-              <a:t>A Spark pipeline and a </a:t>
+              <a:t>The platform takes transaction data from a </a:t>
             </a:r>
             <a:r>
               <a:rPr b="1" i="0" lang="en-IN" u="none" cap="none" strike="noStrike">
@@ -11941,7 +11941,7 @@
                 <a:cs typeface="Times New Roman"/>
                 <a:sym typeface="Times New Roman"/>
               </a:rPr>
-              <a:t>60-tree Random Forest</a:t>
+              <a:t>Spark pipeline or a CSV upload</a:t>
             </a:r>
             <a:r>
               <a:rPr b="0" i="0" lang="en-IN" u="none" cap="none" strike="noStrike">
@@ -11953,7 +11953,7 @@
                 <a:cs typeface="Times New Roman"/>
                 <a:sym typeface="Times New Roman"/>
               </a:rPr>
-              <a:t> find 99.75% of frauds with 99.3% precision on unseen test data, far above the dataset's own rule (0.2% recall).</a:t>
+              <a:t> to model scores, instant search and investigated cases in one system.</a:t>
             </a:r>
             <a:endParaRPr b="0" i="0" u="none" cap="none" strike="noStrike">
               <a:solidFill>
@@ -11993,7 +11993,7 @@
                 <a:cs typeface="Times New Roman"/>
                 <a:sym typeface="Times New Roman"/>
               </a:rPr>
-              <a:t>An </a:t>
+              <a:t>A </a:t>
             </a:r>
             <a:r>
               <a:rPr b="1" i="0" lang="en-IN" u="none" cap="none" strike="noStrike">
@@ -12005,7 +12005,7 @@
                 <a:cs typeface="Times New Roman"/>
                 <a:sym typeface="Times New Roman"/>
               </a:rPr>
-              <a:t>index</a:t>
+              <a:t>60-tree Random Forest</a:t>
             </a:r>
             <a:r>
               <a:rPr b="1" i="0" lang="en-IN" u="none" cap="none" strike="noStrike">
@@ -12017,7 +12017,7 @@
                 <a:cs typeface="Times New Roman"/>
                 <a:sym typeface="Times New Roman"/>
               </a:rPr>
-              <a:t> makes account lookup 574 times faster than a Spark scan, so search and suggestions answer in milliseconds.</a:t>
+              <a:t> finds 99.75% of frauds at 99.3% precision on held-out data and scores about 426,000 rows per second.</a:t>
             </a:r>
             <a:endParaRPr b="0" i="0" u="none" cap="none" strike="noStrike">
               <a:solidFill>
@@ -12048,7 +12048,7 @@
               <a:buChar char="•"/>
             </a:pPr>
             <a:r>
-              <a:rPr b="0" i="0" lang="en-IN" u="none" cap="none" strike="noStrike">
+              <a:rPr b="1" i="0" lang="en-IN" u="none" cap="none" strike="noStrike">
                 <a:solidFill>
                   <a:schemeClr val="dk1"/>
                 </a:solidFill>
@@ -12057,19 +12057,7 @@
                 <a:cs typeface="Times New Roman"/>
                 <a:sym typeface="Times New Roman"/>
               </a:rPr>
-              <a:t>Cases (CRUD) and </a:t>
-            </a:r>
-            <a:r>
-              <a:rPr b="1" i="0" lang="en-IN" u="none" cap="none" strike="noStrike">
-                <a:solidFill>
-                  <a:schemeClr val="dk1"/>
-                </a:solidFill>
-                <a:latin typeface="Times New Roman"/>
-                <a:ea typeface="Times New Roman"/>
-                <a:cs typeface="Times New Roman"/>
-                <a:sym typeface="Times New Roman"/>
-              </a:rPr>
-              <a:t>streaming upload</a:t>
+              <a:t>Indexes</a:t>
             </a:r>
             <a:r>
               <a:rPr b="0" i="0" lang="en-IN" u="none" cap="none" strike="noStrike">
@@ -12081,7 +12069,7 @@
                 <a:cs typeface="Times New Roman"/>
                 <a:sym typeface="Times New Roman"/>
               </a:rPr>
-              <a:t> turn the model into an investigation tool; 8-million-row files are scored and explorable in about a minute.</a:t>
+              <a:t> make lookups 574 times faster than a Spark scan; uploads of 8 million rows are scored and explorable in about a minute.</a:t>
             </a:r>
             <a:endParaRPr b="0" i="0" u="none" cap="none" strike="noStrike">
               <a:solidFill>
@@ -12161,7 +12149,7 @@
       </p:sp>
       <p:pic>
         <p:nvPicPr>
-          <p:cNvPr id="136" name="Picture 135" descr="fig_overview_top.png"/>
+          <p:cNvPr id="136" name="Picture 135" descr="fig_cases.png"/>
           <p:cNvPicPr>
             <a:picLocks noChangeAspect="1"/>
           </p:cNvPicPr>
@@ -12175,8 +12163,8 @@
         </p:blipFill>
         <p:spPr>
           <a:xfrm>
-            <a:off x="4849906" y="1362223"/>
-            <a:ext cx="3743531" cy="2356835"/>
+            <a:off x="4849906" y="996463"/>
+            <a:ext cx="3743531" cy="3147488"/>
           </a:xfrm>
           <a:prstGeom prst="rect">
             <a:avLst/>
@@ -12510,7 +12498,7 @@
                 <a:cs typeface="Times New Roman"/>
                 <a:sym typeface="Times New Roman"/>
               </a:rPr>
-              <a:t>[4] E. A. Lopez-Rojas, A. Elmir and S. Axelsson, “PaySim: A financial mobile money simulator for fraud detection,” </a:t>
+              <a:t>[4] M. Stonebraker </a:t>
             </a:r>
             <a:r>
               <a:rPr b="0" i="1" lang="en-IN" sz="1200" u="none" cap="none" strike="noStrike">
@@ -12522,7 +12510,7 @@
                 <a:cs typeface="Times New Roman"/>
                 <a:sym typeface="Times New Roman"/>
               </a:rPr>
-              <a:t>Proc. EMSS</a:t>
+              <a:t>et al.</a:t>
             </a:r>
             <a:r>
               <a:rPr b="0" i="0" lang="en-IN" sz="1200" u="none" cap="none" strike="noStrike">
@@ -12534,7 +12522,7 @@
                 <a:cs typeface="Times New Roman"/>
                 <a:sym typeface="Times New Roman"/>
               </a:rPr>
-              <a:t>, 2016.</a:t>
+              <a:t>, “C-Store: A Column-oriented DBMS,” Proc. VLDB, 2005.</a:t>
             </a:r>
             <a:endParaRPr b="0" i="0" sz="1400" u="none" cap="none" strike="noStrike">
               <a:solidFill>
@@ -13051,6 +13039,70 @@
                 <a:sym typeface="Times New Roman"/>
               </a:rPr>
               <a:t>duckdb.org/docs</a:t>
+            </a:r>
+            <a:endParaRPr b="0" i="0" sz="1400" u="none" cap="none" strike="noStrike">
+              <a:solidFill>
+                <a:srgbClr val="000000"/>
+              </a:solidFill>
+              <a:latin typeface="Times New Roman"/>
+              <a:ea typeface="Times New Roman"/>
+              <a:cs typeface="Times New Roman"/>
+              <a:sym typeface="Times New Roman"/>
+            </a:endParaRPr>
+          </a:p>
+          <a:p>
+            <a:pPr indent="0" lvl="0" marL="0" marR="0" rtl="0" algn="just">
+              <a:lnSpc>
+                <a:spcPct val="100000"/>
+              </a:lnSpc>
+              <a:spcBef>
+                <a:spcPts val="0"/>
+              </a:spcBef>
+              <a:spcAft>
+                <a:spcPts val="0"/>
+              </a:spcAft>
+              <a:buClr>
+                <a:srgbClr val="000000"/>
+              </a:buClr>
+              <a:buSzPts val="1200"/>
+              <a:buFont typeface="Times New Roman"/>
+              <a:buNone/>
+            </a:pPr>
+            <a:r>
+              <a:rPr b="0" i="0" lang="en-IN" sz="1200" u="none" cap="none" strike="noStrike">
+                <a:solidFill>
+                  <a:srgbClr val="000000"/>
+                </a:solidFill>
+                <a:latin typeface="Times New Roman"/>
+                <a:ea typeface="Times New Roman"/>
+                <a:cs typeface="Times New Roman"/>
+                <a:sym typeface="Times New Roman"/>
+              </a:rPr>
+              <a:t>[14] E. A. Lopez-Rojas, A. Elmir and S. Axelsson, “PaySim: A financial mobile money simulator for fraud detection” (benchmark data), </a:t>
+            </a:r>
+            <a:r>
+              <a:rPr b="0" i="1" lang="en-IN" sz="1200" u="none" cap="none" strike="noStrike">
+                <a:solidFill>
+                  <a:srgbClr val="000000"/>
+                </a:solidFill>
+                <a:latin typeface="Times New Roman"/>
+                <a:ea typeface="Times New Roman"/>
+                <a:cs typeface="Times New Roman"/>
+                <a:sym typeface="Times New Roman"/>
+              </a:rPr>
+              <a:t>Proc. EMSS</a:t>
+            </a:r>
+            <a:r>
+              <a:rPr b="0" i="0" lang="en-IN" sz="1200" u="none" cap="none" strike="noStrike">
+                <a:solidFill>
+                  <a:srgbClr val="000000"/>
+                </a:solidFill>
+                <a:latin typeface="Times New Roman"/>
+                <a:ea typeface="Times New Roman"/>
+                <a:cs typeface="Times New Roman"/>
+                <a:sym typeface="Times New Roman"/>
+              </a:rPr>
+              <a:t>, 2016.</a:t>
             </a:r>
             <a:endParaRPr b="0" i="0" sz="1400" u="none" cap="none" strike="noStrike">
               <a:solidFill>
@@ -13245,7 +13297,7 @@
                 <a:cs typeface="Times New Roman"/>
                 <a:sym typeface="Times New Roman"/>
               </a:rPr>
-              <a:t>Fraud is extremely </a:t>
+              <a:t>Banks must find the </a:t>
             </a:r>
             <a:r>
               <a:rPr b="1" i="0" lang="en-IN" sz="1200" u="none" cap="none" strike="noStrike">
@@ -13260,7 +13312,7 @@
                 <a:cs typeface="Times New Roman"/>
                 <a:sym typeface="Times New Roman"/>
               </a:rPr>
-              <a:t>rare</a:t>
+              <a:t>very few fraudulent transactions</a:t>
             </a:r>
             <a:r>
               <a:rPr b="0" i="0" lang="en-IN" sz="1200" u="none" cap="none" strike="noStrike">
@@ -13275,7 +13327,7 @@
                 <a:cs typeface="Times New Roman"/>
                 <a:sym typeface="Times New Roman"/>
               </a:rPr>
-              <a:t>: in the PaySim data only </a:t>
+              <a:t> hidden among </a:t>
             </a:r>
             <a:r>
               <a:rPr b="1" i="0" lang="en-IN" sz="1200" u="none" cap="none" strike="noStrike">
@@ -13290,7 +13342,7 @@
                 <a:cs typeface="Times New Roman"/>
                 <a:sym typeface="Times New Roman"/>
               </a:rPr>
-              <a:t>8,197 of 6,362,604</a:t>
+              <a:t>millions of legitimate ones</a:t>
             </a:r>
             <a:r>
               <a:rPr b="0" i="0" lang="en-IN" sz="1200" u="none" cap="none" strike="noStrike">
@@ -13305,37 +13357,7 @@
                 <a:cs typeface="Times New Roman"/>
                 <a:sym typeface="Times New Roman"/>
               </a:rPr>
-              <a:t> transactions (</a:t>
-            </a:r>
-            <a:r>
-              <a:rPr b="1" i="0" lang="en-IN" sz="1200" u="none" cap="none" strike="noStrike">
-                <a:solidFill>
-                  <a:srgbClr val="000000"/>
-                </a:solidFill>
-                <a:highlight>
-                  <a:srgbClr val="FFFFFF"/>
-                </a:highlight>
-                <a:latin typeface="Times New Roman"/>
-                <a:ea typeface="Times New Roman"/>
-                <a:cs typeface="Times New Roman"/>
-                <a:sym typeface="Times New Roman"/>
-              </a:rPr>
-              <a:t>0.13%</a:t>
-            </a:r>
-            <a:r>
-              <a:rPr b="0" i="0" lang="en-IN" sz="1200" u="none" cap="none" strike="noStrike">
-                <a:solidFill>
-                  <a:srgbClr val="000000"/>
-                </a:solidFill>
-                <a:highlight>
-                  <a:srgbClr val="FFFFFF"/>
-                </a:highlight>
-                <a:latin typeface="Times New Roman"/>
-                <a:ea typeface="Times New Roman"/>
-                <a:cs typeface="Times New Roman"/>
-                <a:sym typeface="Times New Roman"/>
-              </a:rPr>
-              <a:t>) are fraudulent. Existing approaches rely on fixed rules or single-machine notebooks that cannot search, investigate or score data at scale.</a:t>
+              <a:t> and then act on them. Today this work is split across fixed rules, offline notebooks and separate tools, so an analyst cannot search, investigate and check new batches of transactions in one place.</a:t>
             </a:r>
             <a:endParaRPr b="0" i="0" sz="1200" u="none" cap="none" strike="noStrike">
               <a:solidFill>
@@ -13409,7 +13431,7 @@
                 <a:cs typeface="Times New Roman"/>
                 <a:sym typeface="Times New Roman"/>
               </a:rPr>
-              <a:t>Rules miss most fraud:</a:t>
+              <a:t>Rare, imbalanced events:</a:t>
             </a:r>
             <a:r>
               <a:rPr b="1" i="0" lang="en-IN" sz="1200" u="none" cap="none" strike="noStrike">
@@ -13424,7 +13446,7 @@
                 <a:cs typeface="Times New Roman"/>
                 <a:sym typeface="Times New Roman"/>
               </a:rPr>
-              <a:t> The dataset's own rule flags only 16 of 8,197 frauds (recall 0.2%).</a:t>
+              <a:t> Fraud is about 1 in 776 transactions in our benchmark data, so accuracy is meaningless; precision and recall are needed.</a:t>
             </a:r>
             <a:endParaRPr b="0" i="0" sz="1200" u="none" cap="none" strike="noStrike">
               <a:solidFill>
@@ -13467,7 +13489,7 @@
                 <a:cs typeface="Times New Roman"/>
                 <a:sym typeface="Times New Roman"/>
               </a:rPr>
-              <a:t>Accuracy hides the problem:</a:t>
+              <a:t>Rules and notebooks do not scale:</a:t>
             </a:r>
             <a:r>
               <a:rPr b="1" i="0" lang="en-IN" sz="1200" u="none" cap="none" strike="noStrike">
@@ -13482,7 +13504,7 @@
                 <a:cs typeface="Times New Roman"/>
                 <a:sym typeface="Times New Roman"/>
               </a:rPr>
-              <a:t> A model that always says "legitimate" is 99.87% accurate yet useless, so precision and recall are needed.</a:t>
+              <a:t> Fixed rules catch few frauds, and single-machine notebooks cannot process millions of rows.</a:t>
             </a:r>
             <a:endParaRPr b="0" i="0" sz="1200" u="none" cap="none" strike="noStrike">
               <a:solidFill>
@@ -13528,7 +13550,7 @@
                 <a:cs typeface="Times New Roman"/>
                 <a:sym typeface="Times New Roman"/>
               </a:rPr>
-              <a:t>Scale and speed:</a:t>
+              <a:t>Slow lookups:</a:t>
             </a:r>
             <a:r>
               <a:rPr b="1" i="0" lang="en-IN" sz="1200" u="none" cap="none" strike="noStrike">
@@ -13543,7 +13565,7 @@
                 <a:cs typeface="Times New Roman"/>
                 <a:sym typeface="Times New Roman"/>
               </a:rPr>
-              <a:t> A Spark scan to look up one account takes 1.4 s; an analyst needs the answer in milliseconds.</a:t>
+              <a:t> Scanning all the data for one account takes over a second; analysts need answers in milliseconds.</a:t>
             </a:r>
             <a:endParaRPr b="0" i="0" sz="1200" u="none" cap="none" strike="noStrike">
               <a:solidFill>
@@ -13589,7 +13611,7 @@
                 <a:cs typeface="Times New Roman"/>
                 <a:sym typeface="Times New Roman"/>
               </a:rPr>
-              <a:t>Analysis stops at the model:</a:t>
+              <a:t>No workflow:</a:t>
             </a:r>
             <a:r>
               <a:rPr b="1" i="0" lang="en-IN" sz="1200" u="none" cap="none" strike="noStrike">
@@ -13604,7 +13626,7 @@
                 <a:cs typeface="Times New Roman"/>
                 <a:sym typeface="Times New Roman"/>
               </a:rPr>
-              <a:t> Flagged transactions must be searched, investigated as cases, and new files must be scored; most solutions offer none of this.</a:t>
+              <a:t> Flagged transactions need case management, and new files of transactions must be scored and explored without rebuilding the pipeline.</a:t>
             </a:r>
             <a:endParaRPr b="0" i="0" sz="1200" u="none" cap="none" strike="noStrike">
               <a:solidFill>
@@ -15516,7 +15538,7 @@
                           <a:cs typeface="Times New Roman"/>
                           <a:sym typeface="Times New Roman"/>
                         </a:rPr>
-                        <a:t>PaySim: A Financial Mobile Money Simulator for Fraud Detection (Lopez-Rojas et al., 2016)</a:t>
+                        <a:t>C-Store: A Column-oriented DBMS (Stonebraker et al., 2005)</a:t>
                       </a:r>
                       <a:endParaRPr sz="1400" u="none" cap="none" strike="noStrike">
                         <a:latin typeface="Times New Roman"/>
@@ -15560,7 +15582,7 @@
                           <a:cs typeface="Times New Roman"/>
                           <a:sym typeface="Times New Roman"/>
                         </a:rPr>
-                        <a:t>Agent-based simulator calibrated on aggregated logs of a real mobile-money service.</a:t>
+                        <a:t>Designed a database that stores each column separately, with compression and read-optimised storage.</a:t>
                       </a:r>
                       <a:endParaRPr sz="1400" u="none" cap="none" strike="noStrike">
                         <a:latin typeface="Times New Roman"/>
@@ -15604,7 +15626,7 @@
                           <a:cs typeface="Times New Roman"/>
                           <a:sym typeface="Times New Roman"/>
                         </a:rPr>
-                        <a:t>Gives a labelled benchmark of 6.36 million transactions; fraud appears only in transfers and cash-outs.</a:t>
+                        <a:t>Queries touching a few columns read far less data and compress well. The idea behind Parquet and DuckDB.</a:t>
                       </a:r>
                       <a:endParaRPr sz="1400" u="none" cap="none" strike="noStrike">
                         <a:latin typeface="Times New Roman"/>
@@ -15648,7 +15670,7 @@
                           <a:cs typeface="Times New Roman"/>
                           <a:sym typeface="Times New Roman"/>
                         </a:rPr>
-                        <a:t>Simulated data; the fraud pattern is simpler than real fraud.</a:t>
+                        <a:t>Optimised for reads and bulk loads; single-row updates are costly.</a:t>
                       </a:r>
                       <a:endParaRPr sz="1400" u="none" cap="none" strike="noStrike">
                         <a:latin typeface="Times New Roman"/>
@@ -15692,7 +15714,7 @@
                           <a:cs typeface="Times New Roman"/>
                           <a:sym typeface="Times New Roman"/>
                         </a:rPr>
-                        <a:t>Agent-based simulation</a:t>
+                        <a:t>Column storage, compression, projections</a:t>
                       </a:r>
                       <a:endParaRPr sz="1400" u="none" cap="none" strike="noStrike">
                         <a:latin typeface="Times New Roman"/>
@@ -17450,7 +17472,7 @@
                 <a:cs typeface="Times New Roman"/>
                 <a:sym typeface="Times New Roman"/>
               </a:rPr>
-              <a:t>Process Big Data at Scale</a:t>
+              <a:t>Scalable Data Processing</a:t>
             </a:r>
             <a:endParaRPr b="0" i="0" sz="1400" u="none" cap="none" strike="noStrike">
               <a:solidFill>
@@ -17518,7 +17540,7 @@
                 <a:cs typeface="Times New Roman"/>
                 <a:sym typeface="Times New Roman"/>
               </a:rPr>
-              <a:t>Ingest and clean 6.36 million transactions into a partitioned Parquet lake with Spark.</a:t>
+              <a:t>Process millions of transactions with Spark into a columnar data lake.</a:t>
             </a:r>
             <a:endParaRPr b="0" i="0" sz="1200" u="none" cap="none" strike="noStrike">
               <a:solidFill>
@@ -17558,7 +17580,7 @@
                 <a:cs typeface="Times New Roman"/>
                 <a:sym typeface="Times New Roman"/>
               </a:rPr>
-              <a:t>Run Spark SQL analyses of where, when and how fraud occurs.</a:t>
+              <a:t>Accept any transaction file through a validated, streaming upload.</a:t>
             </a:r>
             <a:endParaRPr b="0" i="0" sz="1200" u="none" cap="none" strike="noStrike">
               <a:solidFill>
@@ -17634,7 +17656,7 @@
                 <a:cs typeface="Times New Roman"/>
                 <a:sym typeface="Times New Roman"/>
               </a:rPr>
-              <a:t>Detect Rare Fraud Accurately</a:t>
+              <a:t>Accurate Fraud Detection</a:t>
             </a:r>
             <a:endParaRPr b="0" i="0" sz="1400" u="none" cap="none" strike="noStrike">
               <a:solidFill>
@@ -17730,7 +17752,7 @@
                 <a:cs typeface="Times New Roman"/>
                 <a:sym typeface="Times New Roman"/>
               </a:rPr>
-              <a:t>Train and compare Logistic Regression and Random Forest with Spark MLlib.</a:t>
+              <a:t>Train and compare models with Spark MLlib on imbalanced data.</a:t>
             </a:r>
             <a:endParaRPr b="0" i="0" sz="1200" u="none" cap="none" strike="noStrike">
               <a:solidFill>
@@ -17846,7 +17868,7 @@
                 <a:cs typeface="Times New Roman"/>
                 <a:sym typeface="Times New Roman"/>
               </a:rPr>
-              <a:t>Support Investigation and Upload</a:t>
+              <a:t>Investigation Workflow</a:t>
             </a:r>
             <a:endParaRPr b="0" i="0" sz="1400" u="none" cap="none" strike="noStrike">
               <a:solidFill>
@@ -17982,7 +18004,7 @@
                 <a:cs typeface="Times New Roman"/>
                 <a:sym typeface="Times New Roman"/>
               </a:rPr>
-              <a:t>Score uploaded files of millions of rows and explore them.</a:t>
+              <a:t>Explore, analyse and open cases on any dataset.</a:t>
             </a:r>
             <a:endParaRPr b="0" i="0" sz="1200" u="none" cap="none" strike="noStrike">
               <a:solidFill>
@@ -18058,7 +18080,7 @@
                 <a:cs typeface="Times New Roman"/>
                 <a:sym typeface="Times New Roman"/>
               </a:rPr>
-              <a:t>Enable Instant Search</a:t>
+              <a:t>Instant Search</a:t>
             </a:r>
             <a:endParaRPr b="0" i="0" sz="1400" u="none" cap="none" strike="noStrike">
               <a:solidFill>
@@ -18166,7 +18188,7 @@
                 <a:cs typeface="Times New Roman"/>
                 <a:sym typeface="Times New Roman"/>
               </a:rPr>
-              <a:t>Suggest matching account ids while the user types.</a:t>
+              <a:t>Build an index for each uploaded file as well.</a:t>
             </a:r>
             <a:endParaRPr b="0" i="0" sz="1200" u="none" cap="none" strike="noStrike">
               <a:solidFill>
@@ -18279,8 +18301,8 @@
         </p:blipFill>
         <p:spPr>
           <a:xfrm>
-            <a:off x="1577471" y="868680"/>
-            <a:ext cx="5989058" cy="3977639"/>
+            <a:off x="1889877" y="868680"/>
+            <a:ext cx="5364245" cy="3977639"/>
           </a:xfrm>
           <a:prstGeom prst="rect">
             <a:avLst/>
@@ -18422,7 +18444,7 @@
                 <a:cs typeface="Times New Roman"/>
                 <a:sym typeface="Times New Roman"/>
               </a:rPr>
-              <a:t>Offline Batch Pipeline: </a:t>
+              <a:t>Data Platform: </a:t>
             </a:r>
             <a:r>
               <a:rPr b="0" i="0" lang="en-IN" u="none" cap="none" strike="noStrike">
@@ -18434,7 +18456,7 @@
                 <a:cs typeface="Times New Roman"/>
                 <a:sym typeface="Times New Roman"/>
               </a:rPr>
-              <a:t>Spark ingests 6.36 million transactions into a partitioned Parquet lake, runs 7 SQL analyses and trains the models.</a:t>
+              <a:t>A Spark batch pipeline prepares the bulk data; any CSV file can be uploaded and is validated and streamed through the same scoring.</a:t>
             </a:r>
             <a:endParaRPr b="0" i="0" u="none" cap="none" strike="noStrike">
               <a:solidFill>
@@ -18486,7 +18508,7 @@
                 <a:cs typeface="Times New Roman"/>
                 <a:sym typeface="Times New Roman"/>
               </a:rPr>
-              <a:t>A 60-tree Random Forest scores transfers and cash-outs from nine features, with 99.3% precision and 99.75% recall on held-out data.</a:t>
+              <a:t>A 60-tree Random Forest scores each transaction from nine features. It is trained with Spark MLlib and served without Spark.</a:t>
             </a:r>
             <a:endParaRPr b="0" i="0" u="none" cap="none" strike="noStrike">
               <a:solidFill>
@@ -18538,7 +18560,7 @@
                 <a:cs typeface="Times New Roman"/>
                 <a:sym typeface="Times New Roman"/>
               </a:rPr>
-              <a:t>An indexed table finds an account's transactions in about 2 to 7 ms, with suggestions while the user types.</a:t>
+              <a:t>Every dataset, bulk or uploaded, gets an index, so account lookup and suggestions while typing answer in milliseconds.</a:t>
             </a:r>
             <a:endParaRPr b="0" i="0" u="none" cap="none" strike="noStrike">
               <a:solidFill>
@@ -18630,7 +18652,7 @@
                 <a:cs typeface="Times New Roman"/>
                 <a:sym typeface="Times New Roman"/>
               </a:rPr>
-              <a:t>Upload and Batch Scoring: </a:t>
+              <a:t>One Interface: </a:t>
             </a:r>
             <a:r>
               <a:rPr b="0" i="0" lang="en-IN" u="none" cap="none" strike="noStrike">
@@ -18642,7 +18664,7 @@
                 <a:cs typeface="Times New Roman"/>
                 <a:sym typeface="Times New Roman"/>
               </a:rPr>
-              <a:t>Files of millions of rows are streamed, validated and scored in about a minute, then indexed so they can be explored.</a:t>
+              <a:t>Overview, Explorer, Cases and Upload work on whichever dataset is selected, all through a validated REST API.</a:t>
             </a:r>
             <a:endParaRPr b="0" i="0" u="none" cap="none" strike="noStrike">
               <a:solidFill>
@@ -18791,7 +18813,7 @@
                 <a:cs typeface="Times New Roman"/>
                 <a:sym typeface="Times New Roman"/>
               </a:rPr>
-              <a:t>Table 1: Model Comparison on the Held-out Test Set (831,437 transactions, 2,407 frauds)</a:t>
+              <a:t>Table 1: Model Comparison on Held-out Test Data (831,437 transactions, 2,407 frauds)</a:t>
             </a:r>
             <a:endParaRPr>
               <a:latin typeface="Times New Roman"/>
@@ -19725,7 +19747,7 @@
                           <a:cs typeface="Times New Roman"/>
                           <a:sym typeface="Times New Roman"/>
                         </a:rPr>
-                        <a:t>Dataset rule (isFlaggedFraud)</a:t>
+                        <a:t>Existing rule-based flag</a:t>
                       </a:r>
                       <a:endParaRPr>
                         <a:latin typeface="Times New Roman"/>
@@ -20040,7 +20062,7 @@
                 <a:cs typeface="Times New Roman"/>
                 <a:sym typeface="Times New Roman"/>
               </a:rPr>
-              <a:t>Table 2: Time to Find All Transactions of One Account (6.36 million rows)</a:t>
+              <a:t>Table 2: Platform Performance</a:t>
             </a:r>
             <a:endParaRPr>
               <a:latin typeface="Times New Roman"/>
@@ -20069,10 +20091,9 @@
                 <a:tableStyleId>{A2CE560F-E46D-4558-8A09-8A56FFD5A36B}</a:tableStyleId>
               </a:tblPr>
               <a:tblGrid>
-                <a:gridCol w="3108960"/>
-                <a:gridCol w="1463040"/>
-                <a:gridCol w="1737360"/>
-                <a:gridCol w="1554480"/>
+                <a:gridCol w="2377440"/>
+                <a:gridCol w="2651760"/>
+                <a:gridCol w="3566160"/>
               </a:tblGrid>
               <a:tr h="274320">
                 <a:tc>
@@ -20104,7 +20125,7 @@
                           <a:cs typeface="Times New Roman"/>
                           <a:sym typeface="Times New Roman"/>
                         </a:rPr>
-                        <a:t>Method</a:t>
+                        <a:t>Capability</a:t>
                       </a:r>
                       <a:endParaRPr>
                         <a:latin typeface="Times New Roman"/>
@@ -20145,7 +20166,7 @@
                           <a:cs typeface="Times New Roman"/>
                           <a:sym typeface="Times New Roman"/>
                         </a:rPr>
-                        <a:t>Median</a:t>
+                        <a:t>Measured</a:t>
                       </a:r>
                       <a:endParaRPr>
                         <a:latin typeface="Times New Roman"/>
@@ -20186,48 +20207,7 @@
                           <a:cs typeface="Times New Roman"/>
                           <a:sym typeface="Times New Roman"/>
                         </a:rPr>
-                        <a:t>95th Percentile</a:t>
-                      </a:r>
-                      <a:endParaRPr>
-                        <a:latin typeface="Times New Roman"/>
-                        <a:ea typeface="Times New Roman"/>
-                        <a:cs typeface="Times New Roman"/>
-                        <a:sym typeface="Times New Roman"/>
-                      </a:endParaRPr>
-                    </a:p>
-                  </a:txBody>
-                  <a:tcPr marT="38100" marB="38100" marR="76200" marL="76200"/>
-                </a:tc>
-                <a:tc>
-                  <a:txBody>
-                    <a:bodyPr/>
-                    <a:lstStyle/>
-                    <a:p>
-                      <a:pPr indent="0" lvl="0" marL="0" marR="0" rtl="0" algn="ctr">
-                        <a:lnSpc>
-                          <a:spcPct val="100000"/>
-                        </a:lnSpc>
-                        <a:spcBef>
-                          <a:spcPts val="0"/>
-                        </a:spcBef>
-                        <a:spcAft>
-                          <a:spcPts val="0"/>
-                        </a:spcAft>
-                        <a:buClr>
-                          <a:srgbClr val="000000"/>
-                        </a:buClr>
-                        <a:buSzPts val="1000"/>
-                        <a:buFont typeface="Times New Roman"/>
-                        <a:buNone/>
-                      </a:pPr>
-                      <a:r>
-                        <a:rPr b="1" lang="en-IN" sz="1000" u="none" cap="none" strike="noStrike">
-                          <a:latin typeface="Times New Roman"/>
-                          <a:ea typeface="Times New Roman"/>
-                          <a:cs typeface="Times New Roman"/>
-                          <a:sym typeface="Times New Roman"/>
-                        </a:rPr>
-                        <a:t>Faster than Spark</a:t>
+                        <a:t>Compared with</a:t>
                       </a:r>
                       <a:endParaRPr>
                         <a:latin typeface="Times New Roman"/>
@@ -20270,7 +20250,7 @@
                           <a:cs typeface="Times New Roman"/>
                           <a:sym typeface="Times New Roman"/>
                         </a:rPr>
-                        <a:t>Spark SQL scan of the data lake</a:t>
+                        <a:t>Account lookup with an index</a:t>
                       </a:r>
                       <a:endParaRPr>
                         <a:latin typeface="Times New Roman"/>
@@ -20311,7 +20291,7 @@
                           <a:cs typeface="Times New Roman"/>
                           <a:sym typeface="Times New Roman"/>
                         </a:rPr>
-                        <a:t>1,441 ms</a:t>
+                        <a:t>2.5 ms (median)</a:t>
                       </a:r>
                       <a:endParaRPr>
                         <a:latin typeface="Times New Roman"/>
@@ -20352,48 +20332,7 @@
                           <a:cs typeface="Times New Roman"/>
                           <a:sym typeface="Times New Roman"/>
                         </a:rPr>
-                        <a:t>1,730 ms</a:t>
-                      </a:r>
-                      <a:endParaRPr>
-                        <a:latin typeface="Times New Roman"/>
-                        <a:ea typeface="Times New Roman"/>
-                        <a:cs typeface="Times New Roman"/>
-                        <a:sym typeface="Times New Roman"/>
-                      </a:endParaRPr>
-                    </a:p>
-                  </a:txBody>
-                  <a:tcPr marT="38100" marB="38100" marR="76200" marL="76200"/>
-                </a:tc>
-                <a:tc>
-                  <a:txBody>
-                    <a:bodyPr/>
-                    <a:lstStyle/>
-                    <a:p>
-                      <a:pPr indent="0" lvl="0" marL="0" marR="0" rtl="0" algn="ctr">
-                        <a:lnSpc>
-                          <a:spcPct val="100000"/>
-                        </a:lnSpc>
-                        <a:spcBef>
-                          <a:spcPts val="0"/>
-                        </a:spcBef>
-                        <a:spcAft>
-                          <a:spcPts val="0"/>
-                        </a:spcAft>
-                        <a:buClr>
-                          <a:srgbClr val="000000"/>
-                        </a:buClr>
-                        <a:buSzPts val="900"/>
-                        <a:buFont typeface="Times New Roman"/>
-                        <a:buNone/>
-                      </a:pPr>
-                      <a:r>
-                        <a:rPr lang="en-IN" sz="900" u="none" cap="none" strike="noStrike">
-                          <a:latin typeface="Times New Roman"/>
-                          <a:ea typeface="Times New Roman"/>
-                          <a:cs typeface="Times New Roman"/>
-                          <a:sym typeface="Times New Roman"/>
-                        </a:rPr>
-                        <a:t>1×</a:t>
+                        <a:t>Spark scan of the same data: 1,441 ms (574× slower)</a:t>
                       </a:r>
                       <a:endParaRPr>
                         <a:latin typeface="Times New Roman"/>
@@ -20436,7 +20375,7 @@
                           <a:cs typeface="Times New Roman"/>
                           <a:sym typeface="Times New Roman"/>
                         </a:rPr>
-                        <a:t>DuckDB on the Parquet files</a:t>
+                        <a:t>Suggestions while typing</a:t>
                       </a:r>
                       <a:endParaRPr>
                         <a:latin typeface="Times New Roman"/>
@@ -20477,7 +20416,7 @@
                           <a:cs typeface="Times New Roman"/>
                           <a:sym typeface="Times New Roman"/>
                         </a:rPr>
-                        <a:t>276 ms</a:t>
+                        <a:t>about 8 to 30 ms</a:t>
                       </a:r>
                       <a:endParaRPr>
                         <a:latin typeface="Times New Roman"/>
@@ -20518,48 +20457,7 @@
                           <a:cs typeface="Times New Roman"/>
                           <a:sym typeface="Times New Roman"/>
                         </a:rPr>
-                        <a:t>329 ms</a:t>
-                      </a:r>
-                      <a:endParaRPr>
-                        <a:latin typeface="Times New Roman"/>
-                        <a:ea typeface="Times New Roman"/>
-                        <a:cs typeface="Times New Roman"/>
-                        <a:sym typeface="Times New Roman"/>
-                      </a:endParaRPr>
-                    </a:p>
-                  </a:txBody>
-                  <a:tcPr marT="38100" marB="38100" marR="76200" marL="76200"/>
-                </a:tc>
-                <a:tc>
-                  <a:txBody>
-                    <a:bodyPr/>
-                    <a:lstStyle/>
-                    <a:p>
-                      <a:pPr indent="0" lvl="0" marL="0" marR="0" rtl="0" algn="ctr">
-                        <a:lnSpc>
-                          <a:spcPct val="100000"/>
-                        </a:lnSpc>
-                        <a:spcBef>
-                          <a:spcPts val="0"/>
-                        </a:spcBef>
-                        <a:spcAft>
-                          <a:spcPts val="0"/>
-                        </a:spcAft>
-                        <a:buClr>
-                          <a:srgbClr val="000000"/>
-                        </a:buClr>
-                        <a:buSzPts val="900"/>
-                        <a:buFont typeface="Times New Roman"/>
-                        <a:buNone/>
-                      </a:pPr>
-                      <a:r>
-                        <a:rPr lang="en-IN" sz="900" u="none" cap="none" strike="noStrike">
-                          <a:latin typeface="Times New Roman"/>
-                          <a:ea typeface="Times New Roman"/>
-                          <a:cs typeface="Times New Roman"/>
-                          <a:sym typeface="Times New Roman"/>
-                        </a:rPr>
-                        <a:t>5×</a:t>
+                        <a:t>Up to 10 matching accounts per pause in typing</a:t>
                       </a:r>
                       <a:endParaRPr>
                         <a:latin typeface="Times New Roman"/>
@@ -20602,7 +20500,7 @@
                           <a:cs typeface="Times New Roman"/>
                           <a:sym typeface="Times New Roman"/>
                         </a:rPr>
-                        <a:t>DuckDB table, no index</a:t>
+                        <a:t>Scoring throughput</a:t>
                       </a:r>
                       <a:endParaRPr>
                         <a:latin typeface="Times New Roman"/>
@@ -20643,7 +20541,7 @@
                           <a:cs typeface="Times New Roman"/>
                           <a:sym typeface="Times New Roman"/>
                         </a:rPr>
-                        <a:t>28 ms</a:t>
+                        <a:t>426,000 rows/s</a:t>
                       </a:r>
                       <a:endParaRPr sz="900">
                         <a:latin typeface="Times New Roman"/>
@@ -20684,48 +20582,7 @@
                           <a:cs typeface="Times New Roman"/>
                           <a:sym typeface="Times New Roman"/>
                         </a:rPr>
-                        <a:t>35 ms</a:t>
-                      </a:r>
-                      <a:endParaRPr>
-                        <a:latin typeface="Times New Roman"/>
-                        <a:ea typeface="Times New Roman"/>
-                        <a:cs typeface="Times New Roman"/>
-                        <a:sym typeface="Times New Roman"/>
-                      </a:endParaRPr>
-                    </a:p>
-                  </a:txBody>
-                  <a:tcPr marT="38100" marB="38100" marR="76200" marL="76200"/>
-                </a:tc>
-                <a:tc>
-                  <a:txBody>
-                    <a:bodyPr/>
-                    <a:lstStyle/>
-                    <a:p>
-                      <a:pPr indent="0" lvl="0" marL="0" marR="0" rtl="0" algn="ctr">
-                        <a:lnSpc>
-                          <a:spcPct val="100000"/>
-                        </a:lnSpc>
-                        <a:spcBef>
-                          <a:spcPts val="0"/>
-                        </a:spcBef>
-                        <a:spcAft>
-                          <a:spcPts val="0"/>
-                        </a:spcAft>
-                        <a:buClr>
-                          <a:srgbClr val="000000"/>
-                        </a:buClr>
-                        <a:buSzPts val="900"/>
-                        <a:buFont typeface="Times New Roman"/>
-                        <a:buNone/>
-                      </a:pPr>
-                      <a:r>
-                        <a:rPr lang="en-IN" sz="900" u="none" cap="none" strike="noStrike">
-                          <a:latin typeface="Times New Roman"/>
-                          <a:ea typeface="Times New Roman"/>
-                          <a:cs typeface="Times New Roman"/>
-                          <a:sym typeface="Times New Roman"/>
-                        </a:rPr>
-                        <a:t>51×</a:t>
+                        <a:t>38,000 rows/s without blocks and threads</a:t>
                       </a:r>
                       <a:endParaRPr>
                         <a:latin typeface="Times New Roman"/>
@@ -20771,7 +20628,7 @@
                           <a:cs typeface="Times New Roman"/>
                           <a:sym typeface="Times New Roman"/>
                         </a:rPr>
-                        <a:t>DuckDB table with index (used) ★</a:t>
+                        <a:t>Upload of an 8.0M-row file</a:t>
                       </a:r>
                       <a:endParaRPr>
                         <a:latin typeface="Times New Roman"/>
@@ -20815,7 +20672,7 @@
                           <a:cs typeface="Times New Roman"/>
                           <a:sym typeface="Times New Roman"/>
                         </a:rPr>
-                        <a:t>2.5 ms</a:t>
+                        <a:t>scored in about 30 s, indexed in about 42 s</a:t>
                       </a:r>
                       <a:endParaRPr>
                         <a:latin typeface="Times New Roman"/>
@@ -20859,7 +20716,50 @@
                           <a:cs typeface="Times New Roman"/>
                           <a:sym typeface="Times New Roman"/>
                         </a:rPr>
-                        <a:t>2.8 ms</a:t>
+                        <a:t>Streamed in 16 MB blocks; memory does not grow with file size</a:t>
+                      </a:r>
+                      <a:endParaRPr>
+                        <a:latin typeface="Times New Roman"/>
+                        <a:ea typeface="Times New Roman"/>
+                        <a:cs typeface="Times New Roman"/>
+                        <a:sym typeface="Times New Roman"/>
+                      </a:endParaRPr>
+                    </a:p>
+                  </a:txBody>
+                  <a:tcPr marT="38100" marB="38100" marR="76200" marL="76200"/>
+                </a:tc>
+              </a:tr>
+              <a:tr h="274320">
+                <a:tc>
+                  <a:txBody>
+                    <a:bodyPr/>
+                    <a:lstStyle/>
+                    <a:p>
+                      <a:pPr indent="0" lvl="0" marL="0" marR="0" rtl="0" algn="l">
+                        <a:lnSpc>
+                          <a:spcPct val="100000"/>
+                        </a:lnSpc>
+                        <a:spcBef>
+                          <a:spcPts val="0"/>
+                        </a:spcBef>
+                        <a:spcAft>
+                          <a:spcPts val="0"/>
+                        </a:spcAft>
+                        <a:buClr>
+                          <a:srgbClr val="000000"/>
+                        </a:buClr>
+                        <a:buSzPts val="900"/>
+                        <a:buFont typeface="Times New Roman"/>
+                        <a:buNone/>
+                      </a:pPr>
+                      <a:r>
+                        <a:rPr lang="en-IN" sz="900" u="none" cap="none" strike="noStrike">
+                          <a:latin typeface="Times New Roman"/>
+                          <a:ea typeface="Times New Roman"/>
+                          <a:cs typeface="Times New Roman"/>
+                          <a:sym typeface="Times New Roman"/>
+                        </a:rPr>
+                        <a:t>Automated tests</a:t>
                       </a:r>
                       <a:endParaRPr>
                         <a:latin typeface="Times New Roman"/>
@@ -20894,16 +20794,54 @@
                         <a:buNone/>
                       </a:pPr>
                       <a:r>
-                        <a:rPr b="1" lang="en-IN" sz="900" u="none" cap="none" strike="noStrike">
-                          <a:solidFill>
-                            <a:srgbClr val="C00000"/>
-                          </a:solidFill>
+                        <a:rPr lang="en-IN" sz="900" u="none" cap="none" strike="noStrike">
                           <a:latin typeface="Times New Roman"/>
                           <a:ea typeface="Times New Roman"/>
                           <a:cs typeface="Times New Roman"/>
                           <a:sym typeface="Times New Roman"/>
                         </a:rPr>
-                        <a:t>574×</a:t>
+                        <a:t>144 passing</a:t>
+                      </a:r>
+                      <a:endParaRPr>
+                        <a:latin typeface="Times New Roman"/>
+                        <a:ea typeface="Times New Roman"/>
+                        <a:cs typeface="Times New Roman"/>
+                        <a:sym typeface="Times New Roman"/>
+                      </a:endParaRPr>
+                    </a:p>
+                  </a:txBody>
+                  <a:tcPr marT="38100" marB="38100" marR="76200" marL="76200"/>
+                </a:tc>
+                <a:tc>
+                  <a:txBody>
+                    <a:bodyPr/>
+                    <a:lstStyle/>
+                    <a:p>
+                      <a:pPr indent="0" lvl="0" marL="0" marR="0" rtl="0" algn="ctr">
+                        <a:lnSpc>
+                          <a:spcPct val="100000"/>
+                        </a:lnSpc>
+                        <a:spcBef>
+                          <a:spcPts val="0"/>
+                        </a:spcBef>
+                        <a:spcAft>
+                          <a:spcPts val="0"/>
+                        </a:spcAft>
+                        <a:buClr>
+                          <a:srgbClr val="000000"/>
+                        </a:buClr>
+                        <a:buSzPts val="900"/>
+                        <a:buFont typeface="Times New Roman"/>
+                        <a:buNone/>
+                      </a:pPr>
+                      <a:r>
+                        <a:rPr lang="en-IN" sz="900" u="none" cap="none" strike="noStrike">
+                          <a:latin typeface="Times New Roman"/>
+                          <a:ea typeface="Times New Roman"/>
+                          <a:cs typeface="Times New Roman"/>
+                          <a:sym typeface="Times New Roman"/>
+                        </a:rPr>
+                        <a:t>Scoring matches Spark within 0.00005</a:t>
                       </a:r>
                       <a:endParaRPr>
                         <a:latin typeface="Times New Roman"/>
@@ -20972,7 +20910,7 @@
                 <a:cs typeface="Times New Roman"/>
                 <a:sym typeface="Times New Roman"/>
               </a:rPr>
-              <a:t>★ Unseen generated files: 8.0M rows scored in about 30 s and indexed in about 42 s, finding 92.1% of frauds at 51.8% precision; the 7.0M-row unlabelled file was scored in about 35 s. 144 automated tests pass.</a:t>
+              <a:t>★ Model figures are on held-out benchmark data. On an unseen 8.0M-row uploaded file the model finds 92.1% of frauds at 51.8% precision, an honest result on a different dataset.</a:t>
             </a:r>
             <a:endParaRPr>
               <a:latin typeface="Times New Roman"/>

</xml_diff>